<commit_message>
fix(r25): deck 101 QA repairs — slide 7/13 bullet overflow, slide 9/10/17 captions, voice nits
</commit_message>
<xml_diff>
--- a/presentation/csharp-design-patterns-101-patterns-and-solid.pptx
+++ b/presentation/csharp-design-patterns-101-patterns-and-solid.pptx
@@ -800,7 +800,7 @@
           <a:p>
             <a:r>
               <a:rPr lang="en-US" dirty="0"/>
-              <a:t>Observer, Strategy, and Null Object dissolve under this reading because the force each one resolved, broadcasting to unknown listeners, substituting behavior at a call site, representing an absent value safely, is now resolved by a construct built into the language and checked by the compiler. None of the three disappear because they were wrong when first described; they disappear because the gap they were invented to fill is not there anymore in C#. Composite fails the test in the opposite direction on purpose: no delegate type, no nullable annotation, and no other language feature changes what a consolidated shipment is or how its parts compose, which is why this book keeps Composite's original shape, in idiomatic modern syntax, while letting Observer, Strategy, and Null Object collapse.</a:t>
+              <a:t>Observer, Strategy, and Null Object dissolve under this reading because the force each one resolved, broadcasting to unknown listeners, substituting behavior at a call site, representing an absent value safely, is now resolved by a construct built into the language and checked by the compiler. None of the three disappear because they were wrong when first described; they disappear because the gap they were invented to fill is not there anymore in C#. Composite fails the test in the opposite direction: no delegate type, no nullable annotation, and no other language feature changes what a consolidated shipment is or how its parts compose, which is why this book keeps Composite's original shape, in idiomatic modern syntax, while letting Observer, Strategy, and Null Object collapse.</a:t>
             </a:r>
             <a:endParaRPr lang="en-US" dirty="0"/>
           </a:p>
@@ -1240,7 +1240,7 @@
           <a:p>
             <a:r>
               <a:rPr lang="en-US" dirty="0"/>
-              <a:t>SurchargedRateQuote implements the same IRateQuote interface its wrapped base pricing implements, so a caller that only knows about IRateQuote cannot tell whether it is quoting a bare calculator or one wrapped in an arbitrary stack of surcharges. The proof that this pipeline stays open for extension is a test file that defines a brand-new flat-fee surcharge nowhere in the shipped library, composes it alongside the existing fuel surcharge, and asserts on the combined total, with zero changes required to the calculator, the quote wrapper, or any surcharge that existed before the test was written. Open/Closed is not free: a surcharge abstraction costs a constructor parameter and a small amount of indirection that a single fixed fuel surcharge would not need, and paying that cost ahead of a second surcharge actually arriving is speculation, not Open/Closed design.</a:t>
+              <a:t>SurchargedRateQuote implements the same IRateQuote interface its wrapped base pricing implements, so a caller that only knows about IRateQuote cannot tell whether it is quoting a bare calculator or one wrapped in an arbitrary stack of surcharges. The proof that this pipeline stays open for extension is a test file that defines a brand-new flat-fee surcharge nowhere in the shipped library, composes it alongside the existing fuel surcharge, and asserts on the combined total, with zero changes required to the calculator, the quote wrapper, or any surcharge that existed before the test was written. Open/Closed is not free: a surcharge abstraction costs a constructor parameter and a small amount of indirection that a single fixed fuel surcharge would not need, and paying that cost ahead of a second surcharge arriving is speculation, not Open/Closed design.</a:t>
             </a:r>
             <a:endParaRPr lang="en-US" dirty="0"/>
           </a:p>
@@ -1416,7 +1416,7 @@
           <a:p>
             <a:r>
               <a:rPr lang="en-US" dirty="0"/>
-              <a:t>A shipping backend touches a carrier at two moments that have nothing to do with each other: a prospective customer wants a price before committing to anything, and a customer who already committed wants a shipment booked and later wants to know where it is. A rate-shopping consumer built against one fat interface still carries a constructor parameter for booking and tracking it never calls, and its test has to substitute something for both anyway because the compiler requires the full interface before anything type-checks. Segregating into a rates role and a tracking role, recomposed into one gateway interface only where an implementer genuinely needs both, means a quote-only freight broker integration now implements just the rates role and has nothing left to throw from or fake.</a:t>
+              <a:t>A shipping backend touches a carrier at two moments that have nothing to do with each other: a prospective customer wants a price before committing to anything, and a customer who already committed wants a shipment booked and later wants to know where it is. A rate-shopping consumer built against one fat interface still carries a constructor parameter for booking and tracking it never calls, and its test has to substitute something for both anyway because the compiler requires the full interface before anything type-checks. Segregating into a rates role and a tracking role, recomposed into one gateway interface only where an implementer needs both, means a quote-only freight broker integration now implements just the rates role and has nothing left to throw from or fake.</a:t>
             </a:r>
             <a:endParaRPr lang="en-US" dirty="0"/>
           </a:p>
@@ -2296,7 +2296,7 @@
           <a:p>
             <a:r>
               <a:rPr lang="en-US" dirty="0"/>
-              <a:t>Interface Segregation and Dependency Inversion both earn their cost only when a second implementation or a second capability-shaped consumer is actually in the picture; splitting a two-method interface into two single-method interfaces when every consumer already needs every member produces a maze of role types for no consumer's benefit. An assistant asked to add a fuel surcharge as a Decorator sometimes generates the full apparatus, a new interface and a concrete wrapper class, when the codebase's own convention for the same shape is a single delegate field; naming the pattern tells the assistant what contract to honor, not which mechanism satisfies that contract most directly. A reviewer who knows both the pattern and the team's idiom for it catches the oversized version before it merges, the same way a reviewer catches a hand-rolled loop where one built-in query operator would do the same job.</a:t>
+              <a:t>Interface Segregation and Dependency Inversion both earn their cost only when a second implementation or a second capability-shaped consumer is in the picture; splitting a two-method interface into two single-method interfaces when every consumer already needs every member produces a maze of role types for no consumer's benefit. An assistant asked to add a fuel surcharge as a Decorator sometimes generates the full apparatus, a new interface and a concrete wrapper class, when the codebase's own convention for the same shape is a single delegate field; naming the pattern tells the assistant what contract to honor, not which mechanism satisfies that contract most directly. A reviewer who knows both the pattern and the team's idiom for it catches the oversized version before it merges, the same way a reviewer catches a hand-rolled loop where one built-in query operator would do the same job.</a:t>
             </a:r>
             <a:endParaRPr lang="en-US" dirty="0"/>
           </a:p>
@@ -3352,7 +3352,7 @@
           <a:p>
             <a:r>
               <a:rPr lang="en-US" dirty="0"/>
-              <a:t>A developer trained only on the catalogue's abstract-class-and-factory habits reaches for an interface, a concrete class per variation, and a factory the moment a rate quote needs to vary by customer, because that was the only type-safe way to parameterize behavior under the catalogue's original constraints. In C#, the same requirement is a parameter typed as a delegate value. Writing the interface-and-factory version anyway is not more correct; it is several extra types a reviewer has to read, a test suite has to cover, and an assistant has to load into context before it can reason about a one-line change, all to resolve a force the compiler already resolves for free.</a:t>
+              <a:t>A developer trained only on the catalogue's abstract-class-and-factory habits reaches for an interface, a concrete class per variation, and a factory the moment a rate quote needs to vary by customer, because that was the only type-safe way to parameterize behavior under the catalogue's original constraints. In C#, the same requirement is a parameter typed as a delegate value. Writing the interface-and-factory version anyway is not more correct; it is several extra types a reviewer has to read, a test suite has to cover, and an assistant has to load into context before it can reason about a one-line change, all to resolve a force the compiler already resolves on its own.</a:t>
             </a:r>
             <a:endParaRPr lang="en-US" dirty="0"/>
           </a:p>
@@ -4551,7 +4551,7 @@
                 <a:ea typeface="Red Hat Text" pitchFamily="34" charset="-122"/>
                 <a:cs typeface="Red Hat Text" pitchFamily="34" charset="-120"/>
               </a:rPr>
-              <a:t>Quote? and the compiler's flow analysis move the absent-value check into the type signature; a do-nothing stand-in survives only as a deliberate default or test fixture.</a:t>
+              <a:t>Quote? and flow analysis move the absent-value check into the type; a stand-in survives only as a deliberate default.</a:t>
             </a:r>
             <a:endParaRPr lang="en-US" sz="1300" dirty="0"/>
           </a:p>
@@ -5251,7 +5251,7 @@
                 <a:ea typeface="Red Hat Text" pitchFamily="34" charset="-122"/>
                 <a:cs typeface="Red Hat Text" pitchFamily="34" charset="-120"/>
               </a:rPr>
-              <a:t>A pattern name is compressed, checkable design intent: labeling a class a Decorator around a rate quote tells a reviewer it keeps the same interface, delegates the call it does not change, and adds exactly one responsibility, before a line of the body is read.</a:t>
+              <a:t>A pattern name is compressed, checkable design intent: calling a class a Decorator says it keeps the interface, delegates the rest, and adds one responsibility, before the body is read.</a:t>
             </a:r>
             <a:endParaRPr lang="en-US" sz="1550" dirty="0"/>
           </a:p>
@@ -5275,7 +5275,7 @@
                 <a:ea typeface="Red Hat Text" pitchFamily="34" charset="-122"/>
                 <a:cs typeface="Red Hat Text" pitchFamily="34" charset="-120"/>
               </a:rPr>
-              <a:t>The same compression applies below the pattern catalogue, to a domain's own vocabulary: a method named MarkCleared commits to a specific precondition, customs documentation validated, and a specific postcondition, billing may proceed, that a status code typed as a bare integer never states.</a:t>
+              <a:t>The same compression works on domain vocabulary: a method named MarkCleared states a precondition (documentation validated) and a postcondition (billing may proceed) a bare status code never does.</a:t>
             </a:r>
             <a:endParaRPr lang="en-US" sz="1550" dirty="0"/>
           </a:p>
@@ -5299,7 +5299,7 @@
                 <a:ea typeface="Red Hat Text" pitchFamily="34" charset="-122"/>
                 <a:cs typeface="Red Hat Text" pitchFamily="34" charset="-120"/>
               </a:rPr>
-              <a:t>The same compression steers an AI assistant: a request that names the pattern or the lifecycle stage narrows what gets generated toward a known shape, and a name an assistant attaches to its own output is a claim to check, not a guarantee to trust.</a:t>
+              <a:t>It steers an AI assistant too: naming the pattern narrows generation toward a known shape, and a name the assistant attaches to its output is a claim to check, not a guarantee to trust.</a:t>
             </a:r>
             <a:endParaRPr lang="en-US" sz="1550" dirty="0"/>
           </a:p>
@@ -7008,7 +7008,7 @@
                 <a:ea typeface="Red Hat Text" pitchFamily="34" charset="-122"/>
                 <a:cs typeface="Red Hat Text" pitchFamily="34" charset="-120"/>
               </a:rPr>
-              <a:t>A new HazmatHandlingSurcharge, defined only in a test, composes alongside the shipped FuelSurcharge with zero edits to any pricing or surcharge type already shipped.</a:t>
+              <a:t>A new HazmatHandlingSurcharge, defined only in a test, composes with the shipped FuelSurcharge with zero edits to shipped code.</a:t>
             </a:r>
             <a:endParaRPr lang="en-US" sz="1300" dirty="0"/>
           </a:p>
@@ -17437,7 +17437,7 @@
                 <a:ea typeface="Red Hat Text" pitchFamily="34" charset="-122"/>
                 <a:cs typeface="Red Hat Text" pitchFamily="34" charset="-120"/>
               </a:rPr>
-              <a:t>The 1994 object model gave no cheap, type-safe way to pass a piece of behavior around as an ordinary value, so wrapping behavior in an object and passing the object was the only portable option available.</a:t>
+              <a:t>No cheap, type-safe way to pass behavior as an ordinary value, so wrapping behavior in an object was the only portable option.</a:t>
             </a:r>
             <a:endParaRPr lang="en-US" sz="1550" dirty="0"/>
           </a:p>
@@ -17461,7 +17461,7 @@
                 <a:ea typeface="Red Hat Text" pitchFamily="34" charset="-122"/>
                 <a:cs typeface="Red Hat Text" pitchFamily="34" charset="-120"/>
               </a:rPr>
-              <a:t>The same object model gave no type-level way to say a reference could never be absent; every reference was a potential null, so a method with nothing to return picked between a check at every call site or a do-nothing stand-in object.</a:t>
+              <a:t>No type-level way to mark a reference as never-absent, so a method with nothing to return chose between a check at every call site or a do-nothing stand-in.</a:t>
             </a:r>
             <a:endParaRPr lang="en-US" sz="1550" dirty="0"/>
           </a:p>
@@ -17485,7 +17485,7 @@
                 <a:ea typeface="Red Hat Text" pitchFamily="34" charset="-122"/>
                 <a:cs typeface="Red Hat Text" pitchFamily="34" charset="-120"/>
               </a:rPr>
-              <a:t>Those two gaps, no first-class functions and no compiler-checked nullability, explain a disproportionate share of the catalogue's structural ceremony, and C# closes both directly in the language rather than asking every team to re-solve them.</a:t>
+              <a:t>Those two gaps, no first-class functions and no compiler-checked nullability, drive much of the catalogue's structural ceremony. C# closes both in the language.</a:t>
             </a:r>
             <a:endParaRPr lang="en-US" sz="1550" dirty="0"/>
           </a:p>
@@ -18495,7 +18495,7 @@
                 <a:ea typeface="Red Hat Text" pitchFamily="34" charset="-122"/>
                 <a:cs typeface="Red Hat Text" pitchFamily="34" charset="-120"/>
               </a:rPr>
-              <a:t>QuoteRate has no rate-strategy interface, no concrete class per algorithm, and no factory to choose between them: the caller's lambda is the whole solution.</a:t>
+              <a:t>No strategy interface, no class per algorithm, no factory: the caller's lambda is the whole solution.</a:t>
             </a:r>
             <a:endParaRPr lang="en-US" sz="1300" dirty="0"/>
           </a:p>

</xml_diff>